<commit_message>
Atualização de pequenos detalhes no Power Point
</commit_message>
<xml_diff>
--- a/Case Sicoob - Eduardo Bonfim.pptx
+++ b/Case Sicoob - Eduardo Bonfim.pptx
@@ -4804,7 +4804,7 @@
   <p:cSld>
     <p:spTree>
       <p:nvGrpSpPr>
-        <p:cNvPr id="217" name="Shape 217"/>
+        <p:cNvPr id="219" name="Shape 219"/>
         <p:cNvGrpSpPr/>
         <p:nvPr/>
       </p:nvGrpSpPr>
@@ -4818,7 +4818,7 @@
       </p:grpSpPr>
       <p:sp>
         <p:nvSpPr>
-          <p:cNvPr id="218" name="Google Shape;218;g3e1cfdb211b_0_201:notes"/>
+          <p:cNvPr id="220" name="Google Shape;220;g3e1cfdb211b_0_201:notes"/>
           <p:cNvSpPr/>
           <p:nvPr>
             <p:ph idx="2" type="sldImg"/>
@@ -4853,7 +4853,7 @@
       </p:sp>
       <p:sp>
         <p:nvSpPr>
-          <p:cNvPr id="219" name="Google Shape;219;g3e1cfdb211b_0_201:notes"/>
+          <p:cNvPr id="221" name="Google Shape;221;g3e1cfdb211b_0_201:notes"/>
           <p:cNvSpPr txBox="1"/>
           <p:nvPr>
             <p:ph idx="1" type="body"/>
@@ -4903,7 +4903,7 @@
   <p:cSld>
     <p:spTree>
       <p:nvGrpSpPr>
-        <p:cNvPr id="239" name="Shape 239"/>
+        <p:cNvPr id="244" name="Shape 244"/>
         <p:cNvGrpSpPr/>
         <p:nvPr/>
       </p:nvGrpSpPr>
@@ -4917,7 +4917,7 @@
       </p:grpSpPr>
       <p:sp>
         <p:nvSpPr>
-          <p:cNvPr id="240" name="Google Shape;240;g3e1f72349ba_0_22:notes"/>
+          <p:cNvPr id="245" name="Google Shape;245;g3e1f72349ba_0_22:notes"/>
           <p:cNvSpPr/>
           <p:nvPr>
             <p:ph idx="2" type="sldImg"/>
@@ -4952,7 +4952,7 @@
       </p:sp>
       <p:sp>
         <p:nvSpPr>
-          <p:cNvPr id="241" name="Google Shape;241;g3e1f72349ba_0_22:notes"/>
+          <p:cNvPr id="246" name="Google Shape;246;g3e1f72349ba_0_22:notes"/>
           <p:cNvSpPr txBox="1"/>
           <p:nvPr>
             <p:ph idx="1" type="body"/>
@@ -5002,7 +5002,7 @@
   <p:cSld>
     <p:spTree>
       <p:nvGrpSpPr>
-        <p:cNvPr id="246" name="Shape 246"/>
+        <p:cNvPr id="251" name="Shape 251"/>
         <p:cNvGrpSpPr/>
         <p:nvPr/>
       </p:nvGrpSpPr>
@@ -5016,7 +5016,7 @@
       </p:grpSpPr>
       <p:sp>
         <p:nvSpPr>
-          <p:cNvPr id="247" name="Google Shape;247;g3e1f72349ba_0_86:notes"/>
+          <p:cNvPr id="252" name="Google Shape;252;g3e1f72349ba_0_86:notes"/>
           <p:cNvSpPr/>
           <p:nvPr>
             <p:ph idx="2" type="sldImg"/>
@@ -5051,7 +5051,7 @@
       </p:sp>
       <p:sp>
         <p:nvSpPr>
-          <p:cNvPr id="248" name="Google Shape;248;g3e1f72349ba_0_86:notes"/>
+          <p:cNvPr id="253" name="Google Shape;253;g3e1f72349ba_0_86:notes"/>
           <p:cNvSpPr txBox="1"/>
           <p:nvPr>
             <p:ph idx="1" type="body"/>
@@ -5101,7 +5101,7 @@
   <p:cSld>
     <p:spTree>
       <p:nvGrpSpPr>
-        <p:cNvPr id="257" name="Shape 257"/>
+        <p:cNvPr id="262" name="Shape 262"/>
         <p:cNvGrpSpPr/>
         <p:nvPr/>
       </p:nvGrpSpPr>
@@ -5115,7 +5115,7 @@
       </p:grpSpPr>
       <p:sp>
         <p:nvSpPr>
-          <p:cNvPr id="258" name="Google Shape;258;g3e1f72349ba_0_122:notes"/>
+          <p:cNvPr id="263" name="Google Shape;263;g3e1f72349ba_0_122:notes"/>
           <p:cNvSpPr/>
           <p:nvPr>
             <p:ph idx="2" type="sldImg"/>
@@ -5150,7 +5150,7 @@
       </p:sp>
       <p:sp>
         <p:nvSpPr>
-          <p:cNvPr id="259" name="Google Shape;259;g3e1f72349ba_0_122:notes"/>
+          <p:cNvPr id="264" name="Google Shape;264;g3e1f72349ba_0_122:notes"/>
           <p:cNvSpPr txBox="1"/>
           <p:nvPr>
             <p:ph idx="1" type="body"/>
@@ -5200,7 +5200,7 @@
   <p:cSld>
     <p:spTree>
       <p:nvGrpSpPr>
-        <p:cNvPr id="268" name="Shape 268"/>
+        <p:cNvPr id="273" name="Shape 273"/>
         <p:cNvGrpSpPr/>
         <p:nvPr/>
       </p:nvGrpSpPr>
@@ -5214,7 +5214,7 @@
       </p:grpSpPr>
       <p:sp>
         <p:nvSpPr>
-          <p:cNvPr id="269" name="Google Shape;269;g3e1f72349ba_0_107:notes"/>
+          <p:cNvPr id="274" name="Google Shape;274;g3e1f72349ba_0_107:notes"/>
           <p:cNvSpPr/>
           <p:nvPr>
             <p:ph idx="2" type="sldImg"/>
@@ -5249,7 +5249,7 @@
       </p:sp>
       <p:sp>
         <p:nvSpPr>
-          <p:cNvPr id="270" name="Google Shape;270;g3e1f72349ba_0_107:notes"/>
+          <p:cNvPr id="275" name="Google Shape;275;g3e1f72349ba_0_107:notes"/>
           <p:cNvSpPr txBox="1"/>
           <p:nvPr>
             <p:ph idx="1" type="body"/>
@@ -14099,7 +14099,7 @@
         <p:spPr>
           <a:xfrm>
             <a:off x="146700" y="110450"/>
-            <a:ext cx="4222800" cy="2862900"/>
+            <a:ext cx="4222800" cy="2416500"/>
           </a:xfrm>
           <a:prstGeom prst="rect">
             <a:avLst/>
@@ -14125,7 +14125,7 @@
               <a:buNone/>
             </a:pPr>
             <a:r>
-              <a:rPr b="1" lang="en" sz="2900">
+              <a:rPr lang="en" sz="2900">
                 <a:solidFill>
                   <a:schemeClr val="lt1"/>
                 </a:solidFill>
@@ -14134,7 +14134,19 @@
                 <a:cs typeface="Helvetica Neue"/>
                 <a:sym typeface="Helvetica Neue"/>
               </a:rPr>
-              <a:t>A ESCOLHA DAS FERRAMENTAS PREZA PELA CONSISTÊNCIA,</a:t>
+              <a:t>A ESCOLHA DAS FERRAMENTAS PREZA PELA</a:t>
+            </a:r>
+            <a:r>
+              <a:rPr b="1" lang="en" sz="2900">
+                <a:solidFill>
+                  <a:schemeClr val="lt1"/>
+                </a:solidFill>
+                <a:latin typeface="Helvetica Neue"/>
+                <a:ea typeface="Helvetica Neue"/>
+                <a:cs typeface="Helvetica Neue"/>
+                <a:sym typeface="Helvetica Neue"/>
+              </a:rPr>
+              <a:t> CONSISTÊNCIA,</a:t>
             </a:r>
             <a:endParaRPr b="1" sz="2900">
               <a:solidFill>
@@ -14227,7 +14239,7 @@
                 <a:cs typeface="Helvetica Neue Light"/>
                 <a:sym typeface="Helvetica Neue Light"/>
               </a:rPr>
-              <a:t>Modelagem do problema</a:t>
+              <a:t>Modelagem da solução</a:t>
             </a:r>
             <a:endParaRPr sz="800">
               <a:solidFill>
@@ -14250,7 +14262,7 @@
         <p:spPr>
           <a:xfrm>
             <a:off x="4719275" y="540000"/>
-            <a:ext cx="4173600" cy="2770500"/>
+            <a:ext cx="4173600" cy="3570900"/>
           </a:xfrm>
           <a:prstGeom prst="rect">
             <a:avLst/>
@@ -14266,7 +14278,7 @@
           </a:bodyPr>
           <a:lstStyle/>
           <a:p>
-            <a:pPr indent="-381000" lvl="0" marL="457200" rtl="0" algn="l">
+            <a:pPr indent="-355600" lvl="0" marL="457200" rtl="0" algn="l">
               <a:spcBef>
                 <a:spcPts val="0"/>
               </a:spcBef>
@@ -14276,18 +14288,18 @@
               <a:buClr>
                 <a:srgbClr val="003641"/>
               </a:buClr>
-              <a:buSzPts val="2400"/>
+              <a:buSzPts val="2000"/>
               <a:buChar char="●"/>
             </a:pPr>
             <a:r>
-              <a:rPr b="1" lang="en" sz="2400">
+              <a:rPr b="1" lang="en" sz="2000">
                 <a:solidFill>
                   <a:srgbClr val="003641"/>
                 </a:solidFill>
               </a:rPr>
               <a:t>Python</a:t>
             </a:r>
-            <a:endParaRPr b="1" sz="2400">
+            <a:endParaRPr b="1" sz="2000">
               <a:solidFill>
                 <a:srgbClr val="003641"/>
               </a:solidFill>
@@ -14306,14 +14318,14 @@
             <a:r>
               <a:t/>
             </a:r>
-            <a:endParaRPr b="1" sz="2400">
+            <a:endParaRPr b="1" sz="2000">
               <a:solidFill>
                 <a:srgbClr val="003641"/>
               </a:solidFill>
             </a:endParaRPr>
           </a:p>
           <a:p>
-            <a:pPr indent="-381000" lvl="0" marL="457200" rtl="0" algn="l">
+            <a:pPr indent="-355600" lvl="0" marL="457200" rtl="0" algn="l">
               <a:spcBef>
                 <a:spcPts val="0"/>
               </a:spcBef>
@@ -14323,11 +14335,11 @@
               <a:buClr>
                 <a:srgbClr val="003641"/>
               </a:buClr>
-              <a:buSzPts val="2400"/>
+              <a:buSzPts val="2000"/>
               <a:buChar char="●"/>
             </a:pPr>
             <a:r>
-              <a:rPr b="1" lang="en" sz="2400">
+              <a:rPr b="1" lang="en" sz="2000">
                 <a:solidFill>
                   <a:srgbClr val="003641"/>
                 </a:solidFill>
@@ -14335,20 +14347,20 @@
               <a:t>dbt</a:t>
             </a:r>
             <a:br>
-              <a:rPr b="1" lang="en" sz="2400">
+              <a:rPr b="1" lang="en" sz="2000">
                 <a:solidFill>
                   <a:srgbClr val="003641"/>
                 </a:solidFill>
               </a:rPr>
             </a:br>
-            <a:endParaRPr b="1" sz="2400">
+            <a:endParaRPr b="1" sz="2000">
               <a:solidFill>
                 <a:srgbClr val="003641"/>
               </a:solidFill>
             </a:endParaRPr>
           </a:p>
           <a:p>
-            <a:pPr indent="-381000" lvl="0" marL="457200" rtl="0" algn="l">
+            <a:pPr indent="-355600" lvl="0" marL="457200" rtl="0" algn="l">
               <a:spcBef>
                 <a:spcPts val="0"/>
               </a:spcBef>
@@ -14358,32 +14370,32 @@
               <a:buClr>
                 <a:srgbClr val="003641"/>
               </a:buClr>
-              <a:buSzPts val="2400"/>
+              <a:buSzPts val="2000"/>
               <a:buChar char="●"/>
             </a:pPr>
             <a:r>
-              <a:rPr b="1" lang="en" sz="2400">
+              <a:rPr b="1" lang="en" sz="2000">
                 <a:solidFill>
                   <a:srgbClr val="003641"/>
                 </a:solidFill>
               </a:rPr>
-              <a:t>SQL (PostgreSQL)</a:t>
+              <a:t>PostgreSQL</a:t>
             </a:r>
             <a:br>
-              <a:rPr b="1" lang="en" sz="2400">
+              <a:rPr b="1" lang="en" sz="2000">
                 <a:solidFill>
                   <a:srgbClr val="003641"/>
                 </a:solidFill>
               </a:rPr>
             </a:br>
-            <a:endParaRPr b="1" sz="2400">
+            <a:endParaRPr b="1" sz="2000">
               <a:solidFill>
                 <a:srgbClr val="003641"/>
               </a:solidFill>
             </a:endParaRPr>
           </a:p>
           <a:p>
-            <a:pPr indent="-381000" lvl="0" marL="457200" rtl="0" algn="l">
+            <a:pPr indent="-355600" lvl="0" marL="457200" rtl="0" algn="l">
               <a:spcBef>
                 <a:spcPts val="0"/>
               </a:spcBef>
@@ -14393,18 +14405,112 @@
               <a:buClr>
                 <a:srgbClr val="003641"/>
               </a:buClr>
-              <a:buSzPts val="2400"/>
+              <a:buSzPts val="2000"/>
               <a:buChar char="●"/>
             </a:pPr>
             <a:r>
-              <a:rPr b="1" lang="en" sz="2400">
+              <a:rPr b="1" lang="en" sz="2000">
                 <a:solidFill>
                   <a:srgbClr val="003641"/>
                 </a:solidFill>
               </a:rPr>
               <a:t>Docker</a:t>
             </a:r>
-            <a:endParaRPr b="1" sz="2400">
+            <a:endParaRPr b="1" sz="2000">
+              <a:solidFill>
+                <a:srgbClr val="003641"/>
+              </a:solidFill>
+            </a:endParaRPr>
+          </a:p>
+          <a:p>
+            <a:pPr indent="0" lvl="0" marL="457200" rtl="0" algn="l">
+              <a:spcBef>
+                <a:spcPts val="0"/>
+              </a:spcBef>
+              <a:spcAft>
+                <a:spcPts val="0"/>
+              </a:spcAft>
+              <a:buNone/>
+            </a:pPr>
+            <a:r>
+              <a:t/>
+            </a:r>
+            <a:endParaRPr b="1" sz="2000">
+              <a:solidFill>
+                <a:srgbClr val="003641"/>
+              </a:solidFill>
+            </a:endParaRPr>
+          </a:p>
+          <a:p>
+            <a:pPr indent="-355600" lvl="0" marL="457200" rtl="0" algn="l">
+              <a:spcBef>
+                <a:spcPts val="0"/>
+              </a:spcBef>
+              <a:spcAft>
+                <a:spcPts val="0"/>
+              </a:spcAft>
+              <a:buClr>
+                <a:srgbClr val="003641"/>
+              </a:buClr>
+              <a:buSzPts val="2000"/>
+              <a:buChar char="●"/>
+            </a:pPr>
+            <a:r>
+              <a:rPr b="1" lang="en" sz="2000">
+                <a:solidFill>
+                  <a:srgbClr val="003641"/>
+                </a:solidFill>
+              </a:rPr>
+              <a:t>DBeaver</a:t>
+            </a:r>
+            <a:endParaRPr b="1" sz="2000">
+              <a:solidFill>
+                <a:srgbClr val="003641"/>
+              </a:solidFill>
+            </a:endParaRPr>
+          </a:p>
+          <a:p>
+            <a:pPr indent="0" lvl="0" marL="457200" rtl="0" algn="l">
+              <a:spcBef>
+                <a:spcPts val="0"/>
+              </a:spcBef>
+              <a:spcAft>
+                <a:spcPts val="0"/>
+              </a:spcAft>
+              <a:buNone/>
+            </a:pPr>
+            <a:r>
+              <a:t/>
+            </a:r>
+            <a:endParaRPr b="1" sz="2000">
+              <a:solidFill>
+                <a:srgbClr val="003641"/>
+              </a:solidFill>
+            </a:endParaRPr>
+          </a:p>
+          <a:p>
+            <a:pPr indent="-355600" lvl="0" marL="457200" rtl="0" algn="l">
+              <a:spcBef>
+                <a:spcPts val="0"/>
+              </a:spcBef>
+              <a:spcAft>
+                <a:spcPts val="0"/>
+              </a:spcAft>
+              <a:buClr>
+                <a:srgbClr val="003641"/>
+              </a:buClr>
+              <a:buSzPts val="2000"/>
+              <a:buChar char="●"/>
+            </a:pPr>
+            <a:r>
+              <a:rPr b="1" lang="en" sz="2000">
+                <a:solidFill>
+                  <a:srgbClr val="003641"/>
+                </a:solidFill>
+              </a:rPr>
+              <a:t>Claude Sonnet e GPT-4o</a:t>
+            </a:r>
+            <a:endParaRPr b="1" sz="2000">
               <a:solidFill>
                 <a:srgbClr val="003641"/>
               </a:solidFill>
@@ -15527,7 +15633,7 @@
                 <a:cs typeface="Helvetica Neue Light"/>
                 <a:sym typeface="Helvetica Neue Light"/>
               </a:rPr>
-              <a:t>Modelagem do problema</a:t>
+              <a:t>Modelagem da solução</a:t>
             </a:r>
             <a:endParaRPr sz="800">
               <a:solidFill>
@@ -15673,6 +15779,64 @@
           </a:p>
         </p:txBody>
       </p:sp>
+      <p:cxnSp>
+        <p:nvCxnSpPr>
+          <p:cNvPr id="217" name="Google Shape;217;p26"/>
+          <p:cNvCxnSpPr>
+            <a:stCxn id="209" idx="3"/>
+            <a:endCxn id="211" idx="1"/>
+          </p:cNvCxnSpPr>
+          <p:nvPr/>
+        </p:nvCxnSpPr>
+        <p:spPr>
+          <a:xfrm>
+            <a:off x="2719325" y="3303850"/>
+            <a:ext cx="896700" cy="0"/>
+          </a:xfrm>
+          <a:prstGeom prst="straightConnector1">
+            <a:avLst/>
+          </a:prstGeom>
+          <a:noFill/>
+          <a:ln cap="flat" cmpd="sng" w="9525">
+            <a:solidFill>
+              <a:schemeClr val="dk2"/>
+            </a:solidFill>
+            <a:prstDash val="solid"/>
+            <a:round/>
+            <a:headEnd len="med" w="med" type="none"/>
+            <a:tailEnd len="med" w="med" type="triangle"/>
+          </a:ln>
+        </p:spPr>
+      </p:cxnSp>
+      <p:cxnSp>
+        <p:nvCxnSpPr>
+          <p:cNvPr id="218" name="Google Shape;218;p26"/>
+          <p:cNvCxnSpPr>
+            <a:stCxn id="211" idx="3"/>
+            <a:endCxn id="213" idx="1"/>
+          </p:cNvCxnSpPr>
+          <p:nvPr/>
+        </p:nvCxnSpPr>
+        <p:spPr>
+          <a:xfrm>
+            <a:off x="5527950" y="3303850"/>
+            <a:ext cx="896700" cy="0"/>
+          </a:xfrm>
+          <a:prstGeom prst="straightConnector1">
+            <a:avLst/>
+          </a:prstGeom>
+          <a:noFill/>
+          <a:ln cap="flat" cmpd="sng" w="9525">
+            <a:solidFill>
+              <a:schemeClr val="dk2"/>
+            </a:solidFill>
+            <a:prstDash val="solid"/>
+            <a:round/>
+            <a:headEnd len="med" w="med" type="none"/>
+            <a:tailEnd len="med" w="med" type="triangle"/>
+          </a:ln>
+        </p:spPr>
+      </p:cxnSp>
     </p:spTree>
   </p:cSld>
   <p:clrMapOvr>
@@ -15686,7 +15850,7 @@
   <p:cSld>
     <p:spTree>
       <p:nvGrpSpPr>
-        <p:cNvPr id="220" name="Shape 220"/>
+        <p:cNvPr id="222" name="Shape 222"/>
         <p:cNvGrpSpPr/>
         <p:nvPr/>
       </p:nvGrpSpPr>
@@ -15700,7 +15864,7 @@
       </p:grpSpPr>
       <p:sp>
         <p:nvSpPr>
-          <p:cNvPr id="221" name="Google Shape;221;p27"/>
+          <p:cNvPr id="223" name="Google Shape;223;p27"/>
           <p:cNvSpPr/>
           <p:nvPr/>
         </p:nvSpPr>
@@ -15743,7 +15907,7 @@
       </p:sp>
       <p:sp>
         <p:nvSpPr>
-          <p:cNvPr id="222" name="Google Shape;222;p27"/>
+          <p:cNvPr id="224" name="Google Shape;224;p27"/>
           <p:cNvSpPr txBox="1"/>
           <p:nvPr/>
         </p:nvSpPr>
@@ -15785,7 +15949,7 @@
                 <a:cs typeface="Helvetica Neue"/>
                 <a:sym typeface="Helvetica Neue"/>
               </a:rPr>
-              <a:t>CICLO DE VIDA</a:t>
+              <a:t>CICLO DE VIDA DOS DADOS</a:t>
             </a:r>
             <a:endParaRPr sz="1100">
               <a:solidFill>
@@ -15801,7 +15965,7 @@
       </p:sp>
       <p:sp>
         <p:nvSpPr>
-          <p:cNvPr id="223" name="Google Shape;223;p27"/>
+          <p:cNvPr id="225" name="Google Shape;225;p27"/>
           <p:cNvSpPr txBox="1"/>
           <p:nvPr/>
         </p:nvSpPr>
@@ -15846,7 +16010,7 @@
                 <a:cs typeface="Helvetica Neue Light"/>
                 <a:sym typeface="Helvetica Neue Light"/>
               </a:rPr>
-              <a:t>Modelagem do problema</a:t>
+              <a:t>Modelagem da solução</a:t>
             </a:r>
             <a:endParaRPr sz="800">
               <a:solidFill>
@@ -15862,13 +16026,13 @@
       </p:sp>
       <p:sp>
         <p:nvSpPr>
-          <p:cNvPr id="224" name="Google Shape;224;p27"/>
+          <p:cNvPr id="226" name="Google Shape;226;p27"/>
           <p:cNvSpPr/>
           <p:nvPr/>
         </p:nvSpPr>
         <p:spPr>
           <a:xfrm>
-            <a:off x="267713" y="2314500"/>
+            <a:off x="267713" y="1949408"/>
             <a:ext cx="1803900" cy="514500"/>
           </a:xfrm>
           <a:prstGeom prst="rect">
@@ -15925,13 +16089,13 @@
       </p:sp>
       <p:sp>
         <p:nvSpPr>
-          <p:cNvPr id="225" name="Google Shape;225;p27"/>
+          <p:cNvPr id="227" name="Google Shape;227;p27"/>
           <p:cNvSpPr/>
           <p:nvPr/>
         </p:nvSpPr>
         <p:spPr>
           <a:xfrm>
-            <a:off x="2535938" y="2314500"/>
+            <a:off x="2535938" y="1949408"/>
             <a:ext cx="1803900" cy="514500"/>
           </a:xfrm>
           <a:prstGeom prst="rect">
@@ -15988,13 +16152,13 @@
       </p:sp>
       <p:sp>
         <p:nvSpPr>
-          <p:cNvPr id="226" name="Google Shape;226;p27"/>
+          <p:cNvPr id="228" name="Google Shape;228;p27"/>
           <p:cNvSpPr/>
           <p:nvPr/>
         </p:nvSpPr>
         <p:spPr>
           <a:xfrm>
-            <a:off x="4804164" y="2314500"/>
+            <a:off x="4804164" y="1949408"/>
             <a:ext cx="1803900" cy="514500"/>
           </a:xfrm>
           <a:prstGeom prst="rect">
@@ -16051,13 +16215,13 @@
       </p:sp>
       <p:sp>
         <p:nvSpPr>
-          <p:cNvPr id="227" name="Google Shape;227;p27"/>
+          <p:cNvPr id="229" name="Google Shape;229;p27"/>
           <p:cNvSpPr/>
           <p:nvPr/>
         </p:nvSpPr>
         <p:spPr>
           <a:xfrm>
-            <a:off x="7072389" y="2314500"/>
+            <a:off x="7072389" y="1949408"/>
             <a:ext cx="1803900" cy="514500"/>
           </a:xfrm>
           <a:prstGeom prst="rect">
@@ -16114,13 +16278,13 @@
       </p:sp>
       <p:sp>
         <p:nvSpPr>
-          <p:cNvPr id="228" name="Google Shape;228;p27"/>
+          <p:cNvPr id="230" name="Google Shape;230;p27"/>
           <p:cNvSpPr/>
           <p:nvPr/>
         </p:nvSpPr>
         <p:spPr>
           <a:xfrm>
-            <a:off x="7072389" y="1575650"/>
+            <a:off x="7072389" y="1210558"/>
             <a:ext cx="1803900" cy="514500"/>
           </a:xfrm>
           <a:prstGeom prst="rect">
@@ -16177,13 +16341,13 @@
       </p:sp>
       <p:sp>
         <p:nvSpPr>
-          <p:cNvPr id="229" name="Google Shape;229;p27"/>
+          <p:cNvPr id="231" name="Google Shape;231;p27"/>
           <p:cNvSpPr/>
           <p:nvPr/>
         </p:nvSpPr>
         <p:spPr>
           <a:xfrm>
-            <a:off x="7072389" y="3053350"/>
+            <a:off x="7072389" y="2688258"/>
             <a:ext cx="1803900" cy="514500"/>
           </a:xfrm>
           <a:prstGeom prst="rect">
@@ -16240,16 +16404,16 @@
       </p:sp>
       <p:cxnSp>
         <p:nvCxnSpPr>
-          <p:cNvPr id="230" name="Google Shape;230;p27"/>
+          <p:cNvPr id="232" name="Google Shape;232;p27"/>
           <p:cNvCxnSpPr>
-            <a:stCxn id="226" idx="3"/>
-            <a:endCxn id="228" idx="1"/>
+            <a:stCxn id="228" idx="3"/>
+            <a:endCxn id="230" idx="1"/>
           </p:cNvCxnSpPr>
           <p:nvPr/>
         </p:nvCxnSpPr>
         <p:spPr>
           <a:xfrm flipH="1" rot="10800000">
-            <a:off x="6608064" y="1832850"/>
+            <a:off x="6608064" y="1467758"/>
             <a:ext cx="464400" cy="738900"/>
           </a:xfrm>
           <a:prstGeom prst="straightConnector1">
@@ -16269,16 +16433,16 @@
       </p:cxnSp>
       <p:cxnSp>
         <p:nvCxnSpPr>
-          <p:cNvPr id="231" name="Google Shape;231;p27"/>
+          <p:cNvPr id="233" name="Google Shape;233;p27"/>
           <p:cNvCxnSpPr>
-            <a:stCxn id="226" idx="3"/>
-            <a:endCxn id="227" idx="1"/>
+            <a:stCxn id="228" idx="3"/>
+            <a:endCxn id="229" idx="1"/>
           </p:cNvCxnSpPr>
           <p:nvPr/>
         </p:nvCxnSpPr>
         <p:spPr>
           <a:xfrm>
-            <a:off x="6608064" y="2571750"/>
+            <a:off x="6608064" y="2206658"/>
             <a:ext cx="464400" cy="0"/>
           </a:xfrm>
           <a:prstGeom prst="straightConnector1">
@@ -16298,16 +16462,16 @@
       </p:cxnSp>
       <p:cxnSp>
         <p:nvCxnSpPr>
-          <p:cNvPr id="232" name="Google Shape;232;p27"/>
+          <p:cNvPr id="234" name="Google Shape;234;p27"/>
           <p:cNvCxnSpPr>
-            <a:stCxn id="226" idx="3"/>
-            <a:endCxn id="229" idx="1"/>
+            <a:stCxn id="228" idx="3"/>
+            <a:endCxn id="231" idx="1"/>
           </p:cNvCxnSpPr>
           <p:nvPr/>
         </p:nvCxnSpPr>
         <p:spPr>
           <a:xfrm>
-            <a:off x="6608064" y="2571750"/>
+            <a:off x="6608064" y="2206658"/>
             <a:ext cx="464400" cy="738900"/>
           </a:xfrm>
           <a:prstGeom prst="straightConnector1">
@@ -16327,16 +16491,16 @@
       </p:cxnSp>
       <p:cxnSp>
         <p:nvCxnSpPr>
-          <p:cNvPr id="233" name="Google Shape;233;p27"/>
+          <p:cNvPr id="235" name="Google Shape;235;p27"/>
           <p:cNvCxnSpPr>
-            <a:stCxn id="224" idx="3"/>
-            <a:endCxn id="225" idx="1"/>
+            <a:stCxn id="226" idx="3"/>
+            <a:endCxn id="227" idx="1"/>
           </p:cNvCxnSpPr>
           <p:nvPr/>
         </p:nvCxnSpPr>
         <p:spPr>
           <a:xfrm>
-            <a:off x="2071613" y="2571750"/>
+            <a:off x="2071613" y="2206658"/>
             <a:ext cx="464400" cy="0"/>
           </a:xfrm>
           <a:prstGeom prst="straightConnector1">
@@ -16356,16 +16520,16 @@
       </p:cxnSp>
       <p:cxnSp>
         <p:nvCxnSpPr>
-          <p:cNvPr id="234" name="Google Shape;234;p27"/>
+          <p:cNvPr id="236" name="Google Shape;236;p27"/>
           <p:cNvCxnSpPr>
-            <a:stCxn id="225" idx="3"/>
-            <a:endCxn id="226" idx="1"/>
+            <a:stCxn id="227" idx="3"/>
+            <a:endCxn id="228" idx="1"/>
           </p:cNvCxnSpPr>
           <p:nvPr/>
         </p:nvCxnSpPr>
         <p:spPr>
           <a:xfrm>
-            <a:off x="4339838" y="2571750"/>
+            <a:off x="4339838" y="2206658"/>
             <a:ext cx="464400" cy="0"/>
           </a:xfrm>
           <a:prstGeom prst="straightConnector1">
@@ -16385,13 +16549,13 @@
       </p:cxnSp>
       <p:sp>
         <p:nvSpPr>
-          <p:cNvPr id="235" name="Google Shape;235;p27"/>
+          <p:cNvPr id="237" name="Google Shape;237;p27"/>
           <p:cNvSpPr/>
           <p:nvPr/>
         </p:nvSpPr>
         <p:spPr>
           <a:xfrm>
-            <a:off x="267725" y="2829000"/>
+            <a:off x="267725" y="2463908"/>
             <a:ext cx="1803900" cy="987300"/>
           </a:xfrm>
           <a:prstGeom prst="rect">
@@ -16425,9 +16589,17 @@
                   <a:schemeClr val="dk2"/>
                 </a:solidFill>
               </a:rPr>
-              <a:t>Entrada dos dados e alocação na camada crua</a:t>
-            </a:r>
-            <a:endParaRPr sz="1100">
+              <a:t>Entrada dos dados e alocação na camada </a:t>
+            </a:r>
+            <a:r>
+              <a:rPr b="1" lang="en" sz="1100">
+                <a:solidFill>
+                  <a:schemeClr val="dk2"/>
+                </a:solidFill>
+              </a:rPr>
+              <a:t>raw</a:t>
+            </a:r>
+            <a:endParaRPr b="1" sz="1100">
               <a:solidFill>
                 <a:schemeClr val="dk2"/>
               </a:solidFill>
@@ -16437,13 +16609,13 @@
       </p:sp>
       <p:sp>
         <p:nvSpPr>
-          <p:cNvPr id="236" name="Google Shape;236;p27"/>
+          <p:cNvPr id="238" name="Google Shape;238;p27"/>
           <p:cNvSpPr/>
           <p:nvPr/>
         </p:nvSpPr>
         <p:spPr>
           <a:xfrm>
-            <a:off x="2535950" y="2829000"/>
+            <a:off x="2535950" y="2463908"/>
             <a:ext cx="1803900" cy="987300"/>
           </a:xfrm>
           <a:prstGeom prst="rect">
@@ -16477,7 +16649,7 @@
                   <a:schemeClr val="dk2"/>
                 </a:solidFill>
               </a:rPr>
-              <a:t>Trativa dos dados em SQL e adição de regras de negócio</a:t>
+              <a:t>Tratativa dos dados em SQL e adição de regras de negócio</a:t>
             </a:r>
             <a:endParaRPr sz="1100">
               <a:solidFill>
@@ -16489,13 +16661,13 @@
       </p:sp>
       <p:sp>
         <p:nvSpPr>
-          <p:cNvPr id="237" name="Google Shape;237;p27"/>
+          <p:cNvPr id="239" name="Google Shape;239;p27"/>
           <p:cNvSpPr/>
           <p:nvPr/>
         </p:nvSpPr>
         <p:spPr>
           <a:xfrm>
-            <a:off x="4804175" y="2816950"/>
+            <a:off x="4804175" y="2451858"/>
             <a:ext cx="1803900" cy="987300"/>
           </a:xfrm>
           <a:prstGeom prst="rect">
@@ -16541,13 +16713,13 @@
       </p:sp>
       <p:sp>
         <p:nvSpPr>
-          <p:cNvPr id="238" name="Google Shape;238;p27"/>
+          <p:cNvPr id="240" name="Google Shape;240;p27"/>
           <p:cNvSpPr/>
           <p:nvPr/>
         </p:nvSpPr>
         <p:spPr>
           <a:xfrm>
-            <a:off x="4804175" y="3793512"/>
+            <a:off x="4804175" y="3428420"/>
             <a:ext cx="1803900" cy="153300"/>
           </a:xfrm>
           <a:prstGeom prst="rect">
@@ -16587,6 +16759,187 @@
               <a:solidFill>
                 <a:schemeClr val="dk2"/>
               </a:solidFill>
+            </a:endParaRPr>
+          </a:p>
+        </p:txBody>
+      </p:sp>
+      <p:sp>
+        <p:nvSpPr>
+          <p:cNvPr id="241" name="Google Shape;241;p27"/>
+          <p:cNvSpPr/>
+          <p:nvPr/>
+        </p:nvSpPr>
+        <p:spPr>
+          <a:xfrm>
+            <a:off x="2535950" y="3451208"/>
+            <a:ext cx="1803900" cy="987300"/>
+          </a:xfrm>
+          <a:prstGeom prst="rect">
+            <a:avLst/>
+          </a:prstGeom>
+          <a:solidFill>
+            <a:schemeClr val="lt2"/>
+          </a:solidFill>
+          <a:ln>
+            <a:noFill/>
+          </a:ln>
+        </p:spPr>
+        <p:txBody>
+          <a:bodyPr anchorCtr="0" anchor="ctr" bIns="91425" lIns="91425" spcFirstLastPara="1" rIns="91425" wrap="square" tIns="91425">
+            <a:noAutofit/>
+          </a:bodyPr>
+          <a:lstStyle/>
+          <a:p>
+            <a:pPr indent="0" lvl="0" marL="0" rtl="0" algn="l">
+              <a:spcBef>
+                <a:spcPts val="0"/>
+              </a:spcBef>
+              <a:spcAft>
+                <a:spcPts val="0"/>
+              </a:spcAft>
+              <a:buNone/>
+            </a:pPr>
+            <a:r>
+              <a:rPr lang="en" sz="600">
+                <a:solidFill>
+                  <a:schemeClr val="dk2"/>
+                </a:solidFill>
+              </a:rPr>
+              <a:t>Escolha pautada no fato de ser uma ferramenta que já possui uma série de artefatos para construir uma arquitetura escalável, com boa </a:t>
+            </a:r>
+            <a:r>
+              <a:rPr lang="en" sz="600">
+                <a:solidFill>
+                  <a:schemeClr val="dk2"/>
+                </a:solidFill>
+              </a:rPr>
+              <a:t>observabilidad</a:t>
+            </a:r>
+            <a:r>
+              <a:rPr lang="en" sz="600">
+                <a:solidFill>
+                  <a:schemeClr val="dk2"/>
+                </a:solidFill>
+              </a:rPr>
+              <a:t> e possui ferramentas integradas que facilitam testes entre outros tópicos.</a:t>
+            </a:r>
+            <a:endParaRPr sz="600">
+              <a:solidFill>
+                <a:schemeClr val="dk2"/>
+              </a:solidFill>
+            </a:endParaRPr>
+          </a:p>
+        </p:txBody>
+      </p:sp>
+      <p:sp>
+        <p:nvSpPr>
+          <p:cNvPr id="242" name="Google Shape;242;p27"/>
+          <p:cNvSpPr/>
+          <p:nvPr/>
+        </p:nvSpPr>
+        <p:spPr>
+          <a:xfrm>
+            <a:off x="267725" y="3451208"/>
+            <a:ext cx="1803900" cy="514500"/>
+          </a:xfrm>
+          <a:prstGeom prst="rect">
+            <a:avLst/>
+          </a:prstGeom>
+          <a:solidFill>
+            <a:schemeClr val="lt2"/>
+          </a:solidFill>
+          <a:ln>
+            <a:noFill/>
+          </a:ln>
+        </p:spPr>
+        <p:txBody>
+          <a:bodyPr anchorCtr="0" anchor="ctr" bIns="91425" lIns="91425" spcFirstLastPara="1" rIns="91425" wrap="square" tIns="91425">
+            <a:noAutofit/>
+          </a:bodyPr>
+          <a:lstStyle/>
+          <a:p>
+            <a:pPr indent="0" lvl="0" marL="0" rtl="0" algn="l">
+              <a:spcBef>
+                <a:spcPts val="0"/>
+              </a:spcBef>
+              <a:spcAft>
+                <a:spcPts val="0"/>
+              </a:spcAft>
+              <a:buNone/>
+            </a:pPr>
+            <a:r>
+              <a:rPr lang="en" sz="600">
+                <a:solidFill>
+                  <a:schemeClr val="dk2"/>
+                </a:solidFill>
+              </a:rPr>
+              <a:t>Python é flexível, possui diversas ferramentas para trabalhar com dados e manter infraestruturas de dados</a:t>
+            </a:r>
+            <a:endParaRPr sz="600">
+              <a:solidFill>
+                <a:schemeClr val="dk2"/>
+              </a:solidFill>
+            </a:endParaRPr>
+          </a:p>
+        </p:txBody>
+      </p:sp>
+      <p:sp>
+        <p:nvSpPr>
+          <p:cNvPr id="243" name="Google Shape;243;p27"/>
+          <p:cNvSpPr txBox="1"/>
+          <p:nvPr/>
+        </p:nvSpPr>
+        <p:spPr>
+          <a:xfrm>
+            <a:off x="7106" y="4720547"/>
+            <a:ext cx="6278100" cy="431100"/>
+          </a:xfrm>
+          <a:prstGeom prst="rect">
+            <a:avLst/>
+          </a:prstGeom>
+          <a:noFill/>
+          <a:ln>
+            <a:noFill/>
+          </a:ln>
+        </p:spPr>
+        <p:txBody>
+          <a:bodyPr anchorCtr="0" anchor="t" bIns="91425" lIns="91425" spcFirstLastPara="1" rIns="91425" wrap="square" tIns="91425">
+            <a:spAutoFit/>
+          </a:bodyPr>
+          <a:lstStyle/>
+          <a:p>
+            <a:pPr indent="0" lvl="0" marL="0" marR="0" rtl="0" algn="l">
+              <a:lnSpc>
+                <a:spcPct val="100000"/>
+              </a:lnSpc>
+              <a:spcBef>
+                <a:spcPts val="0"/>
+              </a:spcBef>
+              <a:spcAft>
+                <a:spcPts val="0"/>
+              </a:spcAft>
+              <a:buNone/>
+            </a:pPr>
+            <a:r>
+              <a:rPr lang="en" sz="800">
+                <a:solidFill>
+                  <a:schemeClr val="dk2"/>
+                </a:solidFill>
+                <a:latin typeface="Helvetica Neue Light"/>
+                <a:ea typeface="Helvetica Neue Light"/>
+                <a:cs typeface="Helvetica Neue Light"/>
+                <a:sym typeface="Helvetica Neue Light"/>
+              </a:rPr>
+              <a:t>Observação: Pela solução ter sido inspirada em pipelines modernos, os DDLs não cobrem relacionamentos. Para validação mais detalhada da integridade referencial do banco, o DBT possui ferramentas como a “relationships” para realizar testes em cima disso.</a:t>
+            </a:r>
+            <a:endParaRPr sz="800">
+              <a:solidFill>
+                <a:schemeClr val="dk2"/>
+              </a:solidFill>
+              <a:latin typeface="Helvetica Neue Light"/>
+              <a:ea typeface="Helvetica Neue Light"/>
+              <a:cs typeface="Helvetica Neue Light"/>
+              <a:sym typeface="Helvetica Neue Light"/>
             </a:endParaRPr>
           </a:p>
         </p:txBody>
@@ -16604,7 +16957,7 @@
   <p:cSld>
     <p:spTree>
       <p:nvGrpSpPr>
-        <p:cNvPr id="242" name="Shape 242"/>
+        <p:cNvPr id="247" name="Shape 247"/>
         <p:cNvGrpSpPr/>
         <p:nvPr/>
       </p:nvGrpSpPr>
@@ -16618,7 +16971,7 @@
       </p:grpSpPr>
       <p:sp>
         <p:nvSpPr>
-          <p:cNvPr id="243" name="Google Shape;243;p28"/>
+          <p:cNvPr id="248" name="Google Shape;248;p28"/>
           <p:cNvSpPr/>
           <p:nvPr/>
         </p:nvSpPr>
@@ -16661,7 +17014,7 @@
       </p:sp>
       <p:sp>
         <p:nvSpPr>
-          <p:cNvPr id="244" name="Google Shape;244;p28"/>
+          <p:cNvPr id="249" name="Google Shape;249;p28"/>
           <p:cNvSpPr txBox="1"/>
           <p:nvPr/>
         </p:nvSpPr>
@@ -16722,7 +17075,7 @@
       </p:sp>
       <p:sp>
         <p:nvSpPr>
-          <p:cNvPr id="245" name="Google Shape;245;p28"/>
+          <p:cNvPr id="250" name="Google Shape;250;p28"/>
           <p:cNvSpPr txBox="1"/>
           <p:nvPr/>
         </p:nvSpPr>
@@ -16791,7 +17144,7 @@
   <p:cSld>
     <p:spTree>
       <p:nvGrpSpPr>
-        <p:cNvPr id="249" name="Shape 249"/>
+        <p:cNvPr id="254" name="Shape 254"/>
         <p:cNvGrpSpPr/>
         <p:nvPr/>
       </p:nvGrpSpPr>
@@ -16805,7 +17158,7 @@
       </p:grpSpPr>
       <p:sp>
         <p:nvSpPr>
-          <p:cNvPr id="250" name="Google Shape;250;p29"/>
+          <p:cNvPr id="255" name="Google Shape;255;p29"/>
           <p:cNvSpPr/>
           <p:nvPr/>
         </p:nvSpPr>
@@ -16848,7 +17201,7 @@
       </p:sp>
       <p:sp>
         <p:nvSpPr>
-          <p:cNvPr id="251" name="Google Shape;251;p29"/>
+          <p:cNvPr id="256" name="Google Shape;256;p29"/>
           <p:cNvSpPr txBox="1"/>
           <p:nvPr/>
         </p:nvSpPr>
@@ -16909,7 +17262,7 @@
       </p:sp>
       <p:sp>
         <p:nvSpPr>
-          <p:cNvPr id="252" name="Google Shape;252;p29"/>
+          <p:cNvPr id="257" name="Google Shape;257;p29"/>
           <p:cNvSpPr txBox="1"/>
           <p:nvPr/>
         </p:nvSpPr>
@@ -16991,7 +17344,7 @@
       </p:sp>
       <p:sp>
         <p:nvSpPr>
-          <p:cNvPr id="253" name="Google Shape;253;p29"/>
+          <p:cNvPr id="258" name="Google Shape;258;p29"/>
           <p:cNvSpPr txBox="1"/>
           <p:nvPr/>
         </p:nvSpPr>
@@ -17049,14 +17402,14 @@
       </p:sp>
       <p:sp>
         <p:nvSpPr>
-          <p:cNvPr id="254" name="Google Shape;254;p29"/>
+          <p:cNvPr id="259" name="Google Shape;259;p29"/>
           <p:cNvSpPr txBox="1"/>
           <p:nvPr/>
         </p:nvSpPr>
         <p:spPr>
           <a:xfrm>
             <a:off x="199100" y="1326472"/>
-            <a:ext cx="4173600" cy="1477500"/>
+            <a:ext cx="4173600" cy="1693200"/>
           </a:xfrm>
           <a:prstGeom prst="rect">
             <a:avLst/>
@@ -17096,7 +17449,7 @@
                 <a:cs typeface="Helvetica Neue"/>
                 <a:sym typeface="Helvetica Neue"/>
               </a:rPr>
-              <a:t>Ranking de cooperados: Bonificação</a:t>
+              <a:t>Ranking de cooperados e clientes: Bonificação e programas de incentivo</a:t>
             </a:r>
             <a:endParaRPr>
               <a:solidFill>
@@ -17232,7 +17585,7 @@
       </p:sp>
       <p:sp>
         <p:nvSpPr>
-          <p:cNvPr id="255" name="Google Shape;255;p29"/>
+          <p:cNvPr id="260" name="Google Shape;260;p29"/>
           <p:cNvSpPr txBox="1"/>
           <p:nvPr/>
         </p:nvSpPr>
@@ -17380,7 +17733,7 @@
       </p:sp>
       <p:sp>
         <p:nvSpPr>
-          <p:cNvPr id="256" name="Google Shape;256;p29"/>
+          <p:cNvPr id="261" name="Google Shape;261;p29"/>
           <p:cNvSpPr txBox="1"/>
           <p:nvPr/>
         </p:nvSpPr>
@@ -17449,7 +17802,7 @@
   <p:cSld>
     <p:spTree>
       <p:nvGrpSpPr>
-        <p:cNvPr id="260" name="Shape 260"/>
+        <p:cNvPr id="265" name="Shape 265"/>
         <p:cNvGrpSpPr/>
         <p:nvPr/>
       </p:nvGrpSpPr>
@@ -17463,7 +17816,7 @@
       </p:grpSpPr>
       <p:sp>
         <p:nvSpPr>
-          <p:cNvPr id="261" name="Google Shape;261;p30"/>
+          <p:cNvPr id="266" name="Google Shape;266;p30"/>
           <p:cNvSpPr txBox="1"/>
           <p:nvPr/>
         </p:nvSpPr>
@@ -17524,7 +17877,7 @@
       </p:sp>
       <p:sp>
         <p:nvSpPr>
-          <p:cNvPr id="262" name="Google Shape;262;p30"/>
+          <p:cNvPr id="267" name="Google Shape;267;p30"/>
           <p:cNvSpPr txBox="1"/>
           <p:nvPr/>
         </p:nvSpPr>
@@ -17557,7 +17910,7 @@
               <a:buNone/>
             </a:pPr>
             <a:r>
-              <a:rPr b="1" lang="en" sz="2900">
+              <a:rPr b="1" lang="en" sz="2900" u="sng">
                 <a:solidFill>
                   <a:srgbClr val="003641"/>
                 </a:solidFill>
@@ -17566,7 +17919,67 @@
                 <a:cs typeface="Helvetica Neue"/>
                 <a:sym typeface="Helvetica Neue"/>
               </a:rPr>
-              <a:t>SEGURANÇA DE DADOS: GARANTIA DA CONFIANÇA DO CLIENTE E DO COOPERADO. ALÉM DE CONFIANÇA NO PRÓPRIO PROCESSO.</a:t>
+              <a:t>SEGURANÇA DE DADOS</a:t>
+            </a:r>
+            <a:r>
+              <a:rPr b="1" lang="en" sz="2900">
+                <a:solidFill>
+                  <a:srgbClr val="003641"/>
+                </a:solidFill>
+                <a:latin typeface="Helvetica Neue"/>
+                <a:ea typeface="Helvetica Neue"/>
+                <a:cs typeface="Helvetica Neue"/>
+                <a:sym typeface="Helvetica Neue"/>
+              </a:rPr>
+              <a:t>: GARANTIA </a:t>
+            </a:r>
+            <a:r>
+              <a:rPr lang="en" sz="2900">
+                <a:solidFill>
+                  <a:srgbClr val="003641"/>
+                </a:solidFill>
+                <a:latin typeface="Helvetica Neue"/>
+                <a:ea typeface="Helvetica Neue"/>
+                <a:cs typeface="Helvetica Neue"/>
+                <a:sym typeface="Helvetica Neue"/>
+              </a:rPr>
+              <a:t>DA CONFIANÇA POR </a:t>
+            </a:r>
+            <a:r>
+              <a:rPr b="1" lang="en" sz="2900">
+                <a:solidFill>
+                  <a:srgbClr val="003641"/>
+                </a:solidFill>
+                <a:latin typeface="Helvetica Neue"/>
+                <a:ea typeface="Helvetica Neue"/>
+                <a:cs typeface="Helvetica Neue"/>
+                <a:sym typeface="Helvetica Neue"/>
+              </a:rPr>
+              <a:t>PARTE DO CLIENTE E DO COOPERADO. </a:t>
+            </a:r>
+            <a:r>
+              <a:rPr lang="en" sz="2900">
+                <a:solidFill>
+                  <a:srgbClr val="003641"/>
+                </a:solidFill>
+                <a:latin typeface="Helvetica Neue"/>
+                <a:ea typeface="Helvetica Neue"/>
+                <a:cs typeface="Helvetica Neue"/>
+                <a:sym typeface="Helvetica Neue"/>
+              </a:rPr>
+              <a:t>ALÉM DE </a:t>
+            </a:r>
+            <a:r>
+              <a:rPr b="1" lang="en" sz="2900">
+                <a:solidFill>
+                  <a:srgbClr val="003641"/>
+                </a:solidFill>
+                <a:latin typeface="Helvetica Neue"/>
+                <a:ea typeface="Helvetica Neue"/>
+                <a:cs typeface="Helvetica Neue"/>
+                <a:sym typeface="Helvetica Neue"/>
+              </a:rPr>
+              <a:t>CONFIANÇA NO PRÓPRIO PROCESSO.</a:t>
             </a:r>
             <a:endParaRPr sz="1100">
               <a:solidFill>
@@ -17582,7 +17995,7 @@
       </p:sp>
       <p:sp>
         <p:nvSpPr>
-          <p:cNvPr id="263" name="Google Shape;263;p30"/>
+          <p:cNvPr id="268" name="Google Shape;268;p30"/>
           <p:cNvSpPr/>
           <p:nvPr/>
         </p:nvSpPr>
@@ -17645,7 +18058,7 @@
       </p:sp>
       <p:sp>
         <p:nvSpPr>
-          <p:cNvPr id="264" name="Google Shape;264;p30"/>
+          <p:cNvPr id="269" name="Google Shape;269;p30"/>
           <p:cNvSpPr/>
           <p:nvPr/>
         </p:nvSpPr>
@@ -17708,7 +18121,7 @@
       </p:sp>
       <p:sp>
         <p:nvSpPr>
-          <p:cNvPr id="265" name="Google Shape;265;p30"/>
+          <p:cNvPr id="270" name="Google Shape;270;p30"/>
           <p:cNvSpPr/>
           <p:nvPr/>
         </p:nvSpPr>
@@ -17783,7 +18196,7 @@
       </p:sp>
       <p:sp>
         <p:nvSpPr>
-          <p:cNvPr id="266" name="Google Shape;266;p30"/>
+          <p:cNvPr id="271" name="Google Shape;271;p30"/>
           <p:cNvSpPr/>
           <p:nvPr/>
         </p:nvSpPr>
@@ -17846,7 +18259,7 @@
       </p:sp>
       <p:sp>
         <p:nvSpPr>
-          <p:cNvPr id="267" name="Google Shape;267;p30"/>
+          <p:cNvPr id="272" name="Google Shape;272;p30"/>
           <p:cNvSpPr/>
           <p:nvPr/>
         </p:nvSpPr>
@@ -17920,7 +18333,7 @@
   <p:cSld>
     <p:spTree>
       <p:nvGrpSpPr>
-        <p:cNvPr id="271" name="Shape 271"/>
+        <p:cNvPr id="276" name="Shape 276"/>
         <p:cNvGrpSpPr/>
         <p:nvPr/>
       </p:nvGrpSpPr>
@@ -17934,7 +18347,7 @@
       </p:grpSpPr>
       <p:sp>
         <p:nvSpPr>
-          <p:cNvPr id="272" name="Google Shape;272;p31"/>
+          <p:cNvPr id="277" name="Google Shape;277;p31"/>
           <p:cNvSpPr/>
           <p:nvPr/>
         </p:nvSpPr>
@@ -17977,7 +18390,7 @@
       </p:sp>
       <p:sp>
         <p:nvSpPr>
-          <p:cNvPr id="273" name="Google Shape;273;p31"/>
+          <p:cNvPr id="278" name="Google Shape;278;p31"/>
           <p:cNvSpPr txBox="1"/>
           <p:nvPr/>
         </p:nvSpPr>
@@ -18035,7 +18448,7 @@
       </p:sp>
       <p:sp>
         <p:nvSpPr>
-          <p:cNvPr id="274" name="Google Shape;274;p31"/>
+          <p:cNvPr id="279" name="Google Shape;279;p31"/>
           <p:cNvSpPr txBox="1"/>
           <p:nvPr/>
         </p:nvSpPr>
@@ -18110,6 +18523,77 @@
                 <a:sym typeface="Helvetica Neue"/>
               </a:rPr>
               <a:t>14/05/2026</a:t>
+            </a:r>
+            <a:endParaRPr sz="1000">
+              <a:solidFill>
+                <a:schemeClr val="lt1"/>
+              </a:solidFill>
+              <a:latin typeface="Helvetica Neue"/>
+              <a:ea typeface="Helvetica Neue"/>
+              <a:cs typeface="Helvetica Neue"/>
+              <a:sym typeface="Helvetica Neue"/>
+            </a:endParaRPr>
+          </a:p>
+        </p:txBody>
+      </p:sp>
+      <p:sp>
+        <p:nvSpPr>
+          <p:cNvPr id="280" name="Google Shape;280;p31"/>
+          <p:cNvSpPr txBox="1"/>
+          <p:nvPr/>
+        </p:nvSpPr>
+        <p:spPr>
+          <a:xfrm>
+            <a:off x="290375" y="898150"/>
+            <a:ext cx="3877200" cy="492600"/>
+          </a:xfrm>
+          <a:prstGeom prst="rect">
+            <a:avLst/>
+          </a:prstGeom>
+          <a:noFill/>
+          <a:ln>
+            <a:noFill/>
+          </a:ln>
+        </p:spPr>
+        <p:txBody>
+          <a:bodyPr anchorCtr="0" anchor="t" bIns="91425" lIns="91425" spcFirstLastPara="1" rIns="91425" wrap="square" tIns="91425">
+            <a:spAutoFit/>
+          </a:bodyPr>
+          <a:lstStyle/>
+          <a:p>
+            <a:pPr indent="0" lvl="0" marL="0" rtl="0" algn="l">
+              <a:spcBef>
+                <a:spcPts val="0"/>
+              </a:spcBef>
+              <a:spcAft>
+                <a:spcPts val="0"/>
+              </a:spcAft>
+              <a:buNone/>
+            </a:pPr>
+            <a:r>
+              <a:rPr lang="en" sz="1000">
+                <a:solidFill>
+                  <a:schemeClr val="lt1"/>
+                </a:solidFill>
+                <a:latin typeface="Helvetica Neue"/>
+                <a:ea typeface="Helvetica Neue"/>
+                <a:cs typeface="Helvetica Neue"/>
+                <a:sym typeface="Helvetica Neue"/>
+              </a:rPr>
+              <a:t>LINK PARA O REPOSITÓRIO NO GITHUB: </a:t>
+            </a:r>
+            <a:r>
+              <a:rPr lang="en" sz="1000" u="sng">
+                <a:solidFill>
+                  <a:schemeClr val="hlink"/>
+                </a:solidFill>
+                <a:latin typeface="Helvetica Neue"/>
+                <a:ea typeface="Helvetica Neue"/>
+                <a:cs typeface="Helvetica Neue"/>
+                <a:sym typeface="Helvetica Neue"/>
+                <a:hlinkClick r:id="rId3"/>
+              </a:rPr>
+              <a:t>https://github.com/ebbonfimm/case_sicoob_coopllactia</a:t>
             </a:r>
             <a:endParaRPr sz="1000">
               <a:solidFill>
@@ -18419,7 +18903,7 @@
                   <a:srgbClr val="003641"/>
                 </a:solidFill>
               </a:rPr>
-              <a:t>Modelagem do problema: </a:t>
+              <a:t>Modelagem da solução: </a:t>
             </a:r>
             <a:r>
               <a:rPr lang="en">
@@ -18799,7 +19283,7 @@
               <a:buNone/>
             </a:pPr>
             <a:r>
-              <a:rPr b="1" lang="en" sz="2900">
+              <a:rPr lang="en" sz="2900">
                 <a:solidFill>
                   <a:srgbClr val="003641"/>
                 </a:solidFill>
@@ -18810,7 +19294,7 @@
               </a:rPr>
               <a:t>CRESCEMOS…</a:t>
             </a:r>
-            <a:endParaRPr b="1" sz="2900">
+            <a:endParaRPr sz="2900">
               <a:solidFill>
                 <a:srgbClr val="003641"/>
               </a:solidFill>
@@ -19159,7 +19643,7 @@
               <a:buNone/>
             </a:pPr>
             <a:r>
-              <a:rPr b="1" lang="en" sz="2900">
+              <a:rPr lang="en" sz="2900">
                 <a:solidFill>
                   <a:srgbClr val="003641"/>
                 </a:solidFill>
@@ -19168,9 +19652,21 @@
                 <a:cs typeface="Helvetica Neue"/>
                 <a:sym typeface="Helvetica Neue"/>
               </a:rPr>
-              <a:t>QUEREMOS NOS TORNAR A PRINCIPAL FORNECEDORA DA REGIÃO</a:t>
-            </a:r>
-            <a:endParaRPr sz="1100">
+              <a:t>QUEREMOS NOS TORNAR A </a:t>
+            </a:r>
+            <a:r>
+              <a:rPr b="1" lang="en" sz="2900">
+                <a:solidFill>
+                  <a:srgbClr val="003641"/>
+                </a:solidFill>
+                <a:latin typeface="Helvetica Neue"/>
+                <a:ea typeface="Helvetica Neue"/>
+                <a:cs typeface="Helvetica Neue"/>
+                <a:sym typeface="Helvetica Neue"/>
+              </a:rPr>
+              <a:t>PRINCIPAL FORNECEDORA DA REGIÃO</a:t>
+            </a:r>
+            <a:endParaRPr b="1" sz="1100">
               <a:solidFill>
                 <a:srgbClr val="003641"/>
               </a:solidFill>
@@ -19676,7 +20172,7 @@
         <p:spPr>
           <a:xfrm>
             <a:off x="298600" y="693900"/>
-            <a:ext cx="3116700" cy="3755700"/>
+            <a:ext cx="3116700" cy="3309300"/>
           </a:xfrm>
           <a:prstGeom prst="rect">
             <a:avLst/>
@@ -19702,7 +20198,7 @@
               <a:buNone/>
             </a:pPr>
             <a:r>
-              <a:rPr b="1" lang="en" sz="2900">
+              <a:rPr lang="en" sz="2900">
                 <a:solidFill>
                   <a:schemeClr val="lt1"/>
                 </a:solidFill>
@@ -19711,7 +20207,19 @@
                 <a:cs typeface="Helvetica Neue"/>
                 <a:sym typeface="Helvetica Neue"/>
               </a:rPr>
-              <a:t>O CAMINHO MAIS EFICIENTE PARA ALCANÇAR É TRABALHAR BEM COM OS DADOS</a:t>
+              <a:t>O CAMINHO MAIS EFICIENTE PARA ALCANÇAR É</a:t>
+            </a:r>
+            <a:r>
+              <a:rPr b="1" lang="en" sz="2900">
+                <a:solidFill>
+                  <a:schemeClr val="lt1"/>
+                </a:solidFill>
+                <a:latin typeface="Helvetica Neue"/>
+                <a:ea typeface="Helvetica Neue"/>
+                <a:cs typeface="Helvetica Neue"/>
+                <a:sym typeface="Helvetica Neue"/>
+              </a:rPr>
+              <a:t> TRABALHAR BEM COM OS DADOS</a:t>
             </a:r>
             <a:endParaRPr sz="1100">
               <a:solidFill>
@@ -20072,7 +20580,7 @@
               <a:buNone/>
             </a:pPr>
             <a:r>
-              <a:rPr b="1" lang="en" sz="2900">
+              <a:rPr lang="en" sz="2900">
                 <a:solidFill>
                   <a:srgbClr val="003641"/>
                 </a:solidFill>
@@ -20081,7 +20589,51 @@
                 <a:cs typeface="Helvetica Neue"/>
                 <a:sym typeface="Helvetica Neue"/>
               </a:rPr>
-              <a:t>PRIMEIRO É PRECISO ENTENDER COMO TUDO FUNCIONA</a:t>
+              <a:t>PRIMEIRO É PRECISO ENTENDER</a:t>
+            </a:r>
+            <a:r>
+              <a:rPr b="1" lang="en" sz="2900">
+                <a:solidFill>
+                  <a:srgbClr val="003641"/>
+                </a:solidFill>
+                <a:latin typeface="Helvetica Neue"/>
+                <a:ea typeface="Helvetica Neue"/>
+                <a:cs typeface="Helvetica Neue"/>
+                <a:sym typeface="Helvetica Neue"/>
+              </a:rPr>
+              <a:t> </a:t>
+            </a:r>
+            <a:endParaRPr b="1" sz="2900">
+              <a:solidFill>
+                <a:srgbClr val="003641"/>
+              </a:solidFill>
+              <a:latin typeface="Helvetica Neue"/>
+              <a:ea typeface="Helvetica Neue"/>
+              <a:cs typeface="Helvetica Neue"/>
+              <a:sym typeface="Helvetica Neue"/>
+            </a:endParaRPr>
+          </a:p>
+          <a:p>
+            <a:pPr indent="0" lvl="0" marL="0" rtl="0" algn="l">
+              <a:spcBef>
+                <a:spcPts val="0"/>
+              </a:spcBef>
+              <a:spcAft>
+                <a:spcPts val="0"/>
+              </a:spcAft>
+              <a:buNone/>
+            </a:pPr>
+            <a:r>
+              <a:rPr b="1" lang="en" sz="2900">
+                <a:solidFill>
+                  <a:srgbClr val="003641"/>
+                </a:solidFill>
+                <a:latin typeface="Helvetica Neue"/>
+                <a:ea typeface="Helvetica Neue"/>
+                <a:cs typeface="Helvetica Neue"/>
+                <a:sym typeface="Helvetica Neue"/>
+              </a:rPr>
+              <a:t>COMO TUDO FUNCIONA</a:t>
             </a:r>
             <a:endParaRPr sz="1100">
               <a:solidFill>
@@ -20221,7 +20773,7 @@
         </p:nvSpPr>
         <p:spPr>
           <a:xfrm>
-            <a:off x="498750" y="2887475"/>
+            <a:off x="498750" y="2726400"/>
             <a:ext cx="8146500" cy="1523700"/>
           </a:xfrm>
           <a:prstGeom prst="rect">
@@ -20248,7 +20800,7 @@
               <a:buNone/>
             </a:pPr>
             <a:r>
-              <a:rPr b="1" i="1" lang="en" sz="2900">
+              <a:rPr i="1" lang="en" sz="2900">
                 <a:solidFill>
                   <a:schemeClr val="lt1"/>
                 </a:solidFill>

</xml_diff>